<commit_message>
fix: Session 2 no longer gives away the unannounced blorps retest
"Bring your blorps" (Day 2 deck slide 15 and the facilitator page) and
"Keep your blorps safe. We'll see who remembers next week" (slide 8
notes) told people the Session 3 retest was coming. The facilitator
note now says to keep the slips and not mention it. One-day Day 2 deck
rebuilt.

Co-Authored-By: Claude Opus 5.5 <noreply@anthropic.com>
Claude-Session: https://claude.ai/code/session_01T23e3au21JYB2q6tbNCUKC
</commit_message>
<xml_diff>
--- a/site/public/slides/tts-day2-active-beats-passive.pptx
+++ b/site/public/slides/tts-day2-active-beats-passive.pptx
@@ -1667,11 +1667,6 @@
           <a:p>
             <a:r>
               <a:t>  If B wins: 'already. Now imagine a week.'</a:t>
-            </a:r>
-          </a:p>
-          <a:p>
-            <a:r>
-              <a:t>  'Keep your blorps safe. We'll see who remembers next week.'</a:t>
             </a:r>
           </a:p>
           <a:p>
@@ -6499,41 +6494,6 @@
                 <a:latin typeface="Georgia"/>
               </a:rPr>
               <a:t>did it stick?</a:t>
-            </a:r>
-          </a:p>
-        </p:txBody>
-      </p:sp>
-      <p:sp>
-        <p:nvSpPr>
-          <p:cNvPr id="3" name="TextBox 2"/>
-          <p:cNvSpPr txBox="1"/>
-          <p:nvPr/>
-        </p:nvSpPr>
-        <p:spPr>
-          <a:xfrm>
-            <a:off x="914400" y="3840480"/>
-            <a:ext cx="10362895" cy="640080"/>
-          </a:xfrm>
-          <a:prstGeom prst="rect">
-            <a:avLst/>
-          </a:prstGeom>
-          <a:noFill/>
-        </p:spPr>
-        <p:txBody>
-          <a:bodyPr wrap="square" lIns="73152" rIns="73152" anchor="t">
-            <a:spAutoFit/>
-          </a:bodyPr>
-          <a:lstStyle/>
-          <a:p>
-            <a:pPr algn="ctr"/>
-            <a:r>
-              <a:rPr sz="3000" b="0">
-                <a:solidFill>
-                  <a:srgbClr val="4C4F69"/>
-                </a:solidFill>
-                <a:latin typeface="Aptos"/>
-              </a:rPr>
-              <a:t>(Bring your blorps.)</a:t>
             </a:r>
           </a:p>
         </p:txBody>

</xml_diff>

<commit_message>
feat: Session 2's Menti ranking introduces the scale of active learning
The fourth Menti question now asks "what helps you learn most?" with
the four ICAP steps as options (plus the biscuits). The result is held
back, then shown at Make 10 minutes active: what we feel helps, then
the research order, with the learning-pyramid myth named so the room's
chart isn't read as percentages. Day 2 slide 7 and 11 notes and the
facilitator page; one-day Day 2 deck rebuilt.

Co-Authored-By: Claude Opus 5.5 <noreply@anthropic.com>
Claude-Session: https://claude.ai/code/session_01T23e3au21JYB2q6tbNCUKC
</commit_message>
<xml_diff>
--- a/site/public/slides/tts-day2-active-beats-passive.pptx
+++ b/site/public/slides/tts-day2-active-beats-passive.pptx
@@ -491,6 +491,16 @@
           </a:p>
           <a:p>
             <a:r>
+              <a:t>  Back to the ranking from the Menti tour (show the result). That's what we FEEL helps. Research puts them in an order: listening, then doing something with it, then explaining it in your own words, then working it through together. The more people do with an idea, the more they tend to learn.</a:t>
+            </a:r>
+          </a:p>
+          <a:p>
+            <a:r>
+              <a:t>  This is a scale, not percentages: the 'learning pyramid' (5% for lectures, 90% for teaching others) was never measured.</a:t>
+            </a:r>
+          </a:p>
+          <a:p>
+            <a:r>
               <a:t>  Take the session you rebuilt last week. Pick ten minutes. Make learners DO something in its real setting: ward corridor, handover, sim room. Use at least one strategy (the mats stay on the table as a menu).</a:t>
             </a:r>
           </a:p>
@@ -506,7 +516,12 @@
           </a:p>
           <a:p>
             <a:r>
-              <a:t>  Situated learning: design for the real constraints (Lave &amp; Wenger 1991). → /papers/lave-wenger-1991</a:t>
+              <a:t>  Situated learning: design for the real constraints (Lave &amp; Wenger 1991). → /papers/learning-by-taking-part</a:t>
+            </a:r>
+          </a:p>
+          <a:p>
+            <a:r>
+              <a:t>  The scale is ICAP (Chi &amp; Wylie 2014): the broad order is well supported; the exact steps are debated. Like the blorps: what feels like it works today isn't always what lasts. → /theories/active-is-a-scale</a:t>
             </a:r>
           </a:p>
           <a:p>
@@ -531,7 +546,7 @@
           </a:p>
           <a:p>
             <a:r>
-              <a:t>  Circulate: what will learners be doing in minute 3? Which strategy is that?</a:t>
+              <a:t>  Circulate: what will learners be doing in minute 3? Which strategy is that, and which step on the scale?</a:t>
             </a:r>
           </a:p>
         </p:txBody>
@@ -1570,7 +1585,12 @@
           </a:p>
           <a:p>
             <a:r>
-              <a:t>  1 Multiple choice: which of these do you dread most at work? · 2 100 points: you have £100m; split it: housing / family / charity / travel · 3 Pin on image: 'spot the difference' (mask one half in Menti) · 4 Ranking: how do you prefer to learn? discussing / watching YouTube / reading / 'nothing, just biscuits and tea'</a:t>
+              <a:t>  1 Multiple choice: which of these do you dread most at work? · 2 100 points: you have £100m; split it: housing / family / charity / travel · 3 Pin on image: 'spot the difference' (mask one half in Menti) · 4 Ranking: what helps you learn most? listening to a talk / taking notes / explaining it to someone / working it through with colleagues / 'nothing, just biscuits and tea'</a:t>
+            </a:r>
+          </a:p>
+          <a:p>
+            <a:r>
+              <a:t>  Keep the ranking result for 'Make 10 minutes active'. Don't explain it yet.</a:t>
             </a:r>
           </a:p>
           <a:p>

</xml_diff>